<commit_message>
Add embedding layer section to encoding notebook and update lecture slides
- Add Part 2.5: Embedding Layer section bridging tokenization and models
- Include practical demo of nn.Embedding with shape transformation
- Show how to inspect real model's embedding layer (DNABERT-2)
- Update summary with complete pipeline diagram
- Update lecture slides for Day 1
</commit_message>
<xml_diff>
--- a/lecture_slides/1.day1_before_lunch/lecture_1a_intro_gfm.pptx
+++ b/lecture_slides/1.day1_before_lunch/lecture_1a_intro_gfm.pptx
@@ -5,10 +5,10 @@
     <p:sldMasterId id="2147483648" r:id="rId4"/>
   </p:sldMasterIdLst>
   <p:notesMasterIdLst>
-    <p:notesMasterId r:id="rId26"/>
+    <p:notesMasterId r:id="rId25"/>
   </p:notesMasterIdLst>
   <p:handoutMasterIdLst>
-    <p:handoutMasterId r:id="rId27"/>
+    <p:handoutMasterId r:id="rId26"/>
   </p:handoutMasterIdLst>
   <p:sldIdLst>
     <p:sldId id="258" r:id="rId5"/>
@@ -30,8 +30,7 @@
     <p:sldId id="326" r:id="rId21"/>
     <p:sldId id="337" r:id="rId22"/>
     <p:sldId id="321" r:id="rId23"/>
-    <p:sldId id="318" r:id="rId24"/>
-    <p:sldId id="324" r:id="rId25"/>
+    <p:sldId id="324" r:id="rId24"/>
   </p:sldIdLst>
   <p:sldSz cx="12192000" cy="6858000"/>
   <p:notesSz cx="6858000" cy="9144000"/>
@@ -5945,8 +5944,8 @@
       </dsp:nvSpPr>
       <dsp:spPr>
         <a:xfrm>
-          <a:off x="814215" y="804"/>
-          <a:ext cx="2196141" cy="1317684"/>
+          <a:off x="881444" y="1996"/>
+          <a:ext cx="2061683" cy="1237010"/>
         </a:xfrm>
         <a:prstGeom prst="rect">
           <a:avLst/>
@@ -5988,12 +5987,12 @@
         </a:fontRef>
       </dsp:style>
       <dsp:txBody>
-        <a:bodyPr spcFirstLastPara="0" vert="horz" wrap="square" lIns="64770" tIns="64770" rIns="64770" bIns="64770" numCol="1" spcCol="1270" anchor="ctr" anchorCtr="0">
+        <a:bodyPr spcFirstLastPara="0" vert="horz" wrap="square" lIns="57150" tIns="57150" rIns="57150" bIns="57150" numCol="1" spcCol="1270" anchor="ctr" anchorCtr="0">
           <a:noAutofit/>
         </a:bodyPr>
         <a:lstStyle/>
         <a:p>
-          <a:pPr marL="0" lvl="0" indent="0" algn="ctr" defTabSz="755650" rtl="0">
+          <a:pPr marL="0" lvl="0" indent="0" algn="ctr" defTabSz="666750" rtl="0">
             <a:lnSpc>
               <a:spcPct val="90000"/>
             </a:lnSpc>
@@ -6006,14 +6005,14 @@
             <a:buNone/>
           </a:pPr>
           <a:r>
-            <a:rPr lang="en-US" sz="1700" kern="1200" dirty="0"/>
+            <a:rPr lang="en-US" sz="1500" kern="1200" dirty="0"/>
             <a:t>Evolution from specialized sequence models to multimodal genomic understanding</a:t>
           </a:r>
         </a:p>
       </dsp:txBody>
       <dsp:txXfrm>
-        <a:off x="814215" y="804"/>
-        <a:ext cx="2196141" cy="1317684"/>
+        <a:off x="881444" y="1996"/>
+        <a:ext cx="2061683" cy="1237010"/>
       </dsp:txXfrm>
     </dsp:sp>
     <dsp:sp modelId="{FB2096E4-36C7-A748-ADC1-773B697266B1}">
@@ -6023,8 +6022,8 @@
       </dsp:nvSpPr>
       <dsp:spPr>
         <a:xfrm>
-          <a:off x="814215" y="1538104"/>
-          <a:ext cx="2196141" cy="1317684"/>
+          <a:off x="881444" y="1445174"/>
+          <a:ext cx="2061683" cy="1237010"/>
         </a:xfrm>
         <a:prstGeom prst="rect">
           <a:avLst/>
@@ -6066,12 +6065,12 @@
         </a:fontRef>
       </dsp:style>
       <dsp:txBody>
-        <a:bodyPr spcFirstLastPara="0" vert="horz" wrap="square" lIns="64770" tIns="64770" rIns="64770" bIns="64770" numCol="1" spcCol="1270" anchor="ctr" anchorCtr="0">
+        <a:bodyPr spcFirstLastPara="0" vert="horz" wrap="square" lIns="57150" tIns="57150" rIns="57150" bIns="57150" numCol="1" spcCol="1270" anchor="ctr" anchorCtr="0">
           <a:noAutofit/>
         </a:bodyPr>
         <a:lstStyle/>
         <a:p>
-          <a:pPr marL="0" lvl="0" indent="0" algn="ctr" defTabSz="755650" rtl="0">
+          <a:pPr marL="0" lvl="0" indent="0" algn="ctr" defTabSz="666750" rtl="0">
             <a:lnSpc>
               <a:spcPct val="90000"/>
             </a:lnSpc>
@@ -6084,14 +6083,14 @@
             <a:buNone/>
           </a:pPr>
           <a:r>
-            <a:rPr lang="en-US" sz="1700" kern="1200" dirty="0"/>
+            <a:rPr lang="en-US" sz="1500" kern="1200" dirty="0"/>
             <a:t>Increasing ability to model long-range dependencies in genomic data</a:t>
           </a:r>
         </a:p>
       </dsp:txBody>
       <dsp:txXfrm>
-        <a:off x="814215" y="1538104"/>
-        <a:ext cx="2196141" cy="1317684"/>
+        <a:off x="881444" y="1445174"/>
+        <a:ext cx="2061683" cy="1237010"/>
       </dsp:txXfrm>
     </dsp:sp>
     <dsp:sp modelId="{4E6ACD82-9272-F346-BFB0-5B4F59AD570F}">
@@ -6101,8 +6100,8 @@
       </dsp:nvSpPr>
       <dsp:spPr>
         <a:xfrm>
-          <a:off x="814215" y="3075403"/>
-          <a:ext cx="2196141" cy="1317684"/>
+          <a:off x="881444" y="2888353"/>
+          <a:ext cx="2061683" cy="1237010"/>
         </a:xfrm>
         <a:prstGeom prst="rect">
           <a:avLst/>
@@ -6144,12 +6143,12 @@
         </a:fontRef>
       </dsp:style>
       <dsp:txBody>
-        <a:bodyPr spcFirstLastPara="0" vert="horz" wrap="square" lIns="64770" tIns="64770" rIns="64770" bIns="64770" numCol="1" spcCol="1270" anchor="ctr" anchorCtr="0">
+        <a:bodyPr spcFirstLastPara="0" vert="horz" wrap="square" lIns="57150" tIns="57150" rIns="57150" bIns="57150" numCol="1" spcCol="1270" anchor="ctr" anchorCtr="0">
           <a:noAutofit/>
         </a:bodyPr>
         <a:lstStyle/>
         <a:p>
-          <a:pPr marL="0" lvl="0" indent="0" algn="ctr" defTabSz="755650" rtl="0">
+          <a:pPr marL="0" lvl="0" indent="0" algn="ctr" defTabSz="666750" rtl="0">
             <a:lnSpc>
               <a:spcPct val="90000"/>
             </a:lnSpc>
@@ -6162,14 +6161,14 @@
             <a:buNone/>
           </a:pPr>
           <a:r>
-            <a:rPr lang="en-US" sz="1700" kern="1200" dirty="0"/>
+            <a:rPr lang="en-US" sz="1500" kern="1200" dirty="0"/>
             <a:t>Transition from prediction to generation capabilities</a:t>
           </a:r>
         </a:p>
       </dsp:txBody>
       <dsp:txXfrm>
-        <a:off x="814215" y="3075403"/>
-        <a:ext cx="2196141" cy="1317684"/>
+        <a:off x="881444" y="2888353"/>
+        <a:ext cx="2061683" cy="1237010"/>
       </dsp:txXfrm>
     </dsp:sp>
   </dsp:spTree>
@@ -12796,7 +12795,7 @@
           <a:p>
             <a:fld id="{30E08F2E-5F06-4CE2-A139-452A1382A6F0}" type="datetimeFigureOut">
               <a:rPr lang="en-US"/>
-              <a:t>2/10/26</a:t>
+              <a:t>2/11/26</a:t>
             </a:fld>
             <a:endParaRPr/>
           </a:p>
@@ -12961,7 +12960,7 @@
           <a:p>
             <a:fld id="{1A4C5DC6-1594-414D-9341-ABA08739246C}" type="datetimeFigureOut">
               <a:rPr lang="en-US"/>
-              <a:t>2/10/26</a:t>
+              <a:t>2/11/26</a:t>
             </a:fld>
             <a:endParaRPr/>
           </a:p>
@@ -13674,7 +13673,7 @@
           <a:p>
             <a:fld id="{77542409-6A04-4DC6-AC3A-D3758287A8F2}" type="slidenum">
               <a:rPr lang="en-SA" smtClean="0"/>
-              <a:t>21</a:t>
+              <a:t>20</a:t>
             </a:fld>
             <a:endParaRPr lang="en-SA"/>
           </a:p>
@@ -21001,123 +21000,6 @@
 </file>
 
 <file path=ppt/slides/slide20.xml><?xml version="1.0" encoding="utf-8"?>
-<p:sld xmlns:a="http://schemas.openxmlformats.org/drawingml/2006/main" xmlns:r="http://schemas.openxmlformats.org/officeDocument/2006/relationships" xmlns:p="http://schemas.openxmlformats.org/presentationml/2006/main">
-  <p:cSld>
-    <p:spTree>
-      <p:nvGrpSpPr>
-        <p:cNvPr id="1" name=""/>
-        <p:cNvGrpSpPr/>
-        <p:nvPr/>
-      </p:nvGrpSpPr>
-      <p:grpSpPr>
-        <a:xfrm>
-          <a:off x="0" y="0"/>
-          <a:ext cx="0" cy="0"/>
-          <a:chOff x="0" y="0"/>
-          <a:chExt cx="0" cy="0"/>
-        </a:xfrm>
-      </p:grpSpPr>
-      <p:sp>
-        <p:nvSpPr>
-          <p:cNvPr id="2" name="Title 1">
-            <a:extLst>
-              <a:ext uri="{FF2B5EF4-FFF2-40B4-BE49-F238E27FC236}">
-                <a16:creationId xmlns:a16="http://schemas.microsoft.com/office/drawing/2014/main" id="{DCADDCB1-728B-F4E1-8F1E-492D566C6C58}"/>
-              </a:ext>
-            </a:extLst>
-          </p:cNvPr>
-          <p:cNvSpPr>
-            <a:spLocks noGrp="1"/>
-          </p:cNvSpPr>
-          <p:nvPr>
-            <p:ph type="title"/>
-          </p:nvPr>
-        </p:nvSpPr>
-        <p:spPr/>
-        <p:txBody>
-          <a:bodyPr/>
-          <a:lstStyle/>
-          <a:p>
-            <a:endParaRPr lang="en-SA"/>
-          </a:p>
-        </p:txBody>
-      </p:sp>
-      <p:sp>
-        <p:nvSpPr>
-          <p:cNvPr id="3" name="Content Placeholder 2">
-            <a:extLst>
-              <a:ext uri="{FF2B5EF4-FFF2-40B4-BE49-F238E27FC236}">
-                <a16:creationId xmlns:a16="http://schemas.microsoft.com/office/drawing/2014/main" id="{53CF4551-A438-8915-5098-D3C1E366A012}"/>
-              </a:ext>
-            </a:extLst>
-          </p:cNvPr>
-          <p:cNvSpPr>
-            <a:spLocks noGrp="1"/>
-          </p:cNvSpPr>
-          <p:nvPr>
-            <p:ph sz="half" idx="1"/>
-          </p:nvPr>
-        </p:nvSpPr>
-        <p:spPr/>
-        <p:txBody>
-          <a:bodyPr/>
-          <a:lstStyle/>
-          <a:p>
-            <a:endParaRPr lang="en-SA"/>
-          </a:p>
-        </p:txBody>
-      </p:sp>
-      <p:sp>
-        <p:nvSpPr>
-          <p:cNvPr id="4" name="Content Placeholder 3">
-            <a:extLst>
-              <a:ext uri="{FF2B5EF4-FFF2-40B4-BE49-F238E27FC236}">
-                <a16:creationId xmlns:a16="http://schemas.microsoft.com/office/drawing/2014/main" id="{246252A2-A72A-9AED-9582-DB42E1121E78}"/>
-              </a:ext>
-            </a:extLst>
-          </p:cNvPr>
-          <p:cNvSpPr>
-            <a:spLocks noGrp="1"/>
-          </p:cNvSpPr>
-          <p:nvPr>
-            <p:ph sz="half" idx="2"/>
-          </p:nvPr>
-        </p:nvSpPr>
-        <p:spPr/>
-        <p:txBody>
-          <a:bodyPr/>
-          <a:lstStyle/>
-          <a:p>
-            <a:endParaRPr lang="en-SA"/>
-          </a:p>
-        </p:txBody>
-      </p:sp>
-    </p:spTree>
-    <p:extLst>
-      <p:ext uri="{BB962C8B-B14F-4D97-AF65-F5344CB8AC3E}">
-        <p14:creationId xmlns:p14="http://schemas.microsoft.com/office/powerpoint/2010/main" val="2174504114"/>
-      </p:ext>
-    </p:extLst>
-  </p:cSld>
-  <p:clrMapOvr>
-    <a:masterClrMapping/>
-  </p:clrMapOvr>
-  <mc:AlternateContent xmlns:mc="http://schemas.openxmlformats.org/markup-compatibility/2006" xmlns:p14="http://schemas.microsoft.com/office/powerpoint/2010/main">
-    <mc:Choice Requires="p14">
-      <p:transition spd="med" p14:dur="700">
-        <p:fade/>
-      </p:transition>
-    </mc:Choice>
-    <mc:Fallback xmlns="">
-      <p:transition spd="med">
-        <p:fade/>
-      </p:transition>
-    </mc:Fallback>
-  </mc:AlternateContent>
-</p:sld>
-</file>
-
-<file path=ppt/slides/slide21.xml><?xml version="1.0" encoding="utf-8"?>
 <p:sld xmlns:a="http://schemas.openxmlformats.org/drawingml/2006/main" xmlns:r="http://schemas.openxmlformats.org/officeDocument/2006/relationships" xmlns:p="http://schemas.openxmlformats.org/presentationml/2006/main" show="0">
   <p:cSld>
     <p:spTree>
@@ -21936,8 +21818,8 @@
           </a:prstGeom>
         </p:spPr>
       </p:pic>
-      <mc:AlternateContent xmlns:mc="http://schemas.openxmlformats.org/markup-compatibility/2006">
-        <mc:Choice xmlns:a14="http://schemas.microsoft.com/office/drawing/2010/main" Requires="a14">
+      <mc:AlternateContent xmlns:mc="http://schemas.openxmlformats.org/markup-compatibility/2006" xmlns:a14="http://schemas.microsoft.com/office/drawing/2010/main">
+        <mc:Choice Requires="a14">
           <p:sp>
             <p:nvSpPr>
               <p:cNvPr id="4" name="TextBox 3">
@@ -22220,7 +22102,7 @@
             </p:txBody>
           </p:sp>
         </mc:Choice>
-        <mc:Fallback>
+        <mc:Fallback xmlns="">
           <p:sp>
             <p:nvSpPr>
               <p:cNvPr id="4" name="TextBox 3">
@@ -23131,8 +23013,8 @@
         </p:blipFill>
         <p:spPr bwMode="auto">
           <a:xfrm>
-            <a:off x="5234599" y="1659666"/>
-            <a:ext cx="6154890" cy="4526822"/>
+            <a:off x="5234599" y="1659990"/>
+            <a:ext cx="5610879" cy="4126711"/>
           </a:xfrm>
           <a:prstGeom prst="rect">
             <a:avLst/>
@@ -23162,14 +23044,14 @@
           <p:nvPr>
             <p:extLst>
               <p:ext uri="{D42A27DB-BD31-4B8C-83A1-F6EECF244321}">
-                <p14:modId xmlns:p14="http://schemas.microsoft.com/office/powerpoint/2010/main" val="3252694733"/>
+                <p14:modId xmlns:p14="http://schemas.microsoft.com/office/powerpoint/2010/main" val="1549940308"/>
               </p:ext>
             </p:extLst>
           </p:nvPr>
         </p:nvGraphicFramePr>
         <p:xfrm>
-          <a:off x="1410026" y="1659665"/>
-          <a:ext cx="3824573" cy="4393893"/>
+          <a:off x="1410026" y="1659666"/>
+          <a:ext cx="3824573" cy="4127360"/>
         </p:xfrm>
         <a:graphic>
           <a:graphicData uri="http://schemas.openxmlformats.org/drawingml/2006/diagram">
@@ -23253,7 +23135,7 @@
         </p:nvSpPr>
         <p:spPr>
           <a:xfrm>
-            <a:off x="1410025" y="6199078"/>
+            <a:off x="1410025" y="5986391"/>
             <a:ext cx="9371949" cy="461665"/>
           </a:xfrm>
           <a:prstGeom prst="rect">
@@ -23276,6 +23158,59 @@
               </a:rPr>
               <a:t>We will be focusing on genomic foundation models in this workshop</a:t>
             </a:r>
+          </a:p>
+        </p:txBody>
+      </p:sp>
+      <p:sp>
+        <p:nvSpPr>
+          <p:cNvPr id="5" name="Rectangle 4">
+            <a:extLst>
+              <a:ext uri="{FF2B5EF4-FFF2-40B4-BE49-F238E27FC236}">
+                <a16:creationId xmlns:a16="http://schemas.microsoft.com/office/drawing/2014/main" id="{2144CF7A-DF48-0F1D-95F2-B57A69BFC864}"/>
+              </a:ext>
+            </a:extLst>
+          </p:cNvPr>
+          <p:cNvSpPr/>
+          <p:nvPr/>
+        </p:nvSpPr>
+        <p:spPr>
+          <a:xfrm>
+            <a:off x="5523978" y="1659666"/>
+            <a:ext cx="789140" cy="4126712"/>
+          </a:xfrm>
+          <a:prstGeom prst="rect">
+            <a:avLst/>
+          </a:prstGeom>
+          <a:solidFill>
+            <a:schemeClr val="accent2">
+              <a:lumMod val="60000"/>
+              <a:lumOff val="40000"/>
+              <a:alpha val="26714"/>
+            </a:schemeClr>
+          </a:solidFill>
+        </p:spPr>
+        <p:style>
+          <a:lnRef idx="2">
+            <a:schemeClr val="accent1">
+              <a:shade val="15000"/>
+            </a:schemeClr>
+          </a:lnRef>
+          <a:fillRef idx="1">
+            <a:schemeClr val="accent1"/>
+          </a:fillRef>
+          <a:effectRef idx="0">
+            <a:schemeClr val="accent1"/>
+          </a:effectRef>
+          <a:fontRef idx="minor">
+            <a:schemeClr val="lt1"/>
+          </a:fontRef>
+        </p:style>
+        <p:txBody>
+          <a:bodyPr rtlCol="0" anchor="ctr"/>
+          <a:lstStyle/>
+          <a:p>
+            <a:pPr algn="ctr"/>
+            <a:endParaRPr lang="en-SA"/>
           </a:p>
         </p:txBody>
       </p:sp>
@@ -23301,6 +23236,92 @@
       </p:transition>
     </mc:Fallback>
   </mc:AlternateContent>
+  <p:timing>
+    <p:tnLst>
+      <p:par>
+        <p:cTn id="1" dur="indefinite" restart="never" nodeType="tmRoot">
+          <p:childTnLst>
+            <p:seq concurrent="1" nextAc="seek">
+              <p:cTn id="2" dur="indefinite" nodeType="mainSeq">
+                <p:childTnLst>
+                  <p:par>
+                    <p:cTn id="3" fill="hold">
+                      <p:stCondLst>
+                        <p:cond delay="indefinite"/>
+                      </p:stCondLst>
+                      <p:childTnLst>
+                        <p:par>
+                          <p:cTn id="4" fill="hold">
+                            <p:stCondLst>
+                              <p:cond delay="0"/>
+                            </p:stCondLst>
+                            <p:childTnLst>
+                              <p:par>
+                                <p:cTn id="5" presetID="6" presetClass="entr" presetSubtype="16" fill="hold" grpId="0" nodeType="clickEffect">
+                                  <p:stCondLst>
+                                    <p:cond delay="0"/>
+                                  </p:stCondLst>
+                                  <p:childTnLst>
+                                    <p:set>
+                                      <p:cBhvr>
+                                        <p:cTn id="6" dur="1" fill="hold">
+                                          <p:stCondLst>
+                                            <p:cond delay="0"/>
+                                          </p:stCondLst>
+                                        </p:cTn>
+                                        <p:tgtEl>
+                                          <p:spTgt spid="5"/>
+                                        </p:tgtEl>
+                                        <p:attrNameLst>
+                                          <p:attrName>style.visibility</p:attrName>
+                                        </p:attrNameLst>
+                                      </p:cBhvr>
+                                      <p:to>
+                                        <p:strVal val="visible"/>
+                                      </p:to>
+                                    </p:set>
+                                    <p:animEffect transition="in" filter="circle(in)">
+                                      <p:cBhvr>
+                                        <p:cTn id="7" dur="2000"/>
+                                        <p:tgtEl>
+                                          <p:spTgt spid="5"/>
+                                        </p:tgtEl>
+                                      </p:cBhvr>
+                                    </p:animEffect>
+                                  </p:childTnLst>
+                                </p:cTn>
+                              </p:par>
+                            </p:childTnLst>
+                          </p:cTn>
+                        </p:par>
+                      </p:childTnLst>
+                    </p:cTn>
+                  </p:par>
+                </p:childTnLst>
+              </p:cTn>
+              <p:prevCondLst>
+                <p:cond evt="onPrev" delay="0">
+                  <p:tgtEl>
+                    <p:sldTgt/>
+                  </p:tgtEl>
+                </p:cond>
+              </p:prevCondLst>
+              <p:nextCondLst>
+                <p:cond evt="onNext" delay="0">
+                  <p:tgtEl>
+                    <p:sldTgt/>
+                  </p:tgtEl>
+                </p:cond>
+              </p:nextCondLst>
+            </p:seq>
+          </p:childTnLst>
+        </p:cTn>
+      </p:par>
+    </p:tnLst>
+    <p:bldLst>
+      <p:bldP spid="5" grpId="0" animBg="1"/>
+    </p:bldLst>
+  </p:timing>
 </p:sld>
 </file>
 
@@ -24484,26 +24505,6 @@
 </file>
 
 <file path=customXml/item1.xml><?xml version="1.0" encoding="utf-8"?>
-<p:properties xmlns:p="http://schemas.microsoft.com/office/2006/metadata/properties" xmlns:xsi="http://www.w3.org/2001/XMLSchema-instance" xmlns:pc="http://schemas.microsoft.com/office/infopath/2007/PartnerControls">
-  <documentManagement>
-    <_ip_UnifiedCompliancePolicyUIAction xmlns="http://schemas.microsoft.com/sharepoint/v3" xsi:nil="true"/>
-    <Image xmlns="71af3243-3dd4-4a8d-8c0d-dd76da1f02a5">
-      <Url xsi:nil="true"/>
-      <Description xsi:nil="true"/>
-    </Image>
-    <Status xmlns="71af3243-3dd4-4a8d-8c0d-dd76da1f02a5">Not started</Status>
-    <Background xmlns="71af3243-3dd4-4a8d-8c0d-dd76da1f02a5">false</Background>
-    <_ip_UnifiedCompliancePolicyProperties xmlns="http://schemas.microsoft.com/sharepoint/v3" xsi:nil="true"/>
-    <ImageTagsTaxHTField xmlns="71af3243-3dd4-4a8d-8c0d-dd76da1f02a5">
-      <Terms xmlns="http://schemas.microsoft.com/office/infopath/2007/PartnerControls"/>
-    </ImageTagsTaxHTField>
-    <TaxCatchAll xmlns="230e9df3-be65-4c73-a93b-d1236ebd677e" xsi:nil="true"/>
-    <MediaServiceKeyPoints xmlns="71af3243-3dd4-4a8d-8c0d-dd76da1f02a5" xsi:nil="true"/>
-  </documentManagement>
-</p:properties>
-</file>
-
-<file path=customXml/item2.xml><?xml version="1.0" encoding="utf-8"?>
 <?mso-contentType ?>
 <FormTemplates xmlns="http://schemas.microsoft.com/sharepoint/v3/contenttype/forms">
   <Display>DocumentLibraryForm</Display>
@@ -24512,7 +24513,7 @@
 </FormTemplates>
 </file>
 
-<file path=customXml/item3.xml><?xml version="1.0" encoding="utf-8"?>
+<file path=customXml/item2.xml><?xml version="1.0" encoding="utf-8"?>
 <ct:contentTypeSchema xmlns:ct="http://schemas.microsoft.com/office/2006/metadata/contentType" xmlns:ma="http://schemas.microsoft.com/office/2006/metadata/properties/metaAttributes" ct:_="" ma:_="" ma:contentTypeName="Document" ma:contentTypeID="0x01010079F111ED35F8CC479449609E8A0923A6" ma:contentTypeVersion="27" ma:contentTypeDescription="Create a new document." ma:contentTypeScope="" ma:versionID="c6f9a84f66a9c8b9a21755b9ffafb945">
   <xsd:schema xmlns:xsd="http://www.w3.org/2001/XMLSchema" xmlns:xs="http://www.w3.org/2001/XMLSchema" xmlns:p="http://schemas.microsoft.com/office/2006/metadata/properties" xmlns:ns1="http://schemas.microsoft.com/sharepoint/v3" xmlns:ns2="71af3243-3dd4-4a8d-8c0d-dd76da1f02a5" xmlns:ns3="16c05727-aa75-4e4a-9b5f-8a80a1165891" xmlns:ns4="230e9df3-be65-4c73-a93b-d1236ebd677e" targetNamespace="http://schemas.microsoft.com/office/2006/metadata/properties" ma:root="true" ma:fieldsID="27df39e3e7036dff54f89ddd5805ce72" ns1:_="" ns2:_="" ns3:_="" ns4:_="">
     <xsd:import namespace="http://schemas.microsoft.com/sharepoint/v3"/>
@@ -24818,26 +24819,27 @@
 </ct:contentTypeSchema>
 </file>
 
-<file path=customXml/itemProps1.xml><?xml version="1.0" encoding="utf-8"?>
-<ds:datastoreItem xmlns:ds="http://schemas.openxmlformats.org/officeDocument/2006/customXml" ds:itemID="{4D18307F-863E-465D-9426-B14DA0CBD25E}">
-  <ds:schemaRefs>
-    <ds:schemaRef ds:uri="http://schemas.microsoft.com/sharepoint/v3"/>
-    <ds:schemaRef ds:uri="16c05727-aa75-4e4a-9b5f-8a80a1165891"/>
-    <ds:schemaRef ds:uri="http://schemas.microsoft.com/office/2006/metadata/properties"/>
-    <ds:schemaRef ds:uri="http://www.w3.org/XML/1998/namespace"/>
-    <ds:schemaRef ds:uri="230e9df3-be65-4c73-a93b-d1236ebd677e"/>
-    <ds:schemaRef ds:uri="http://purl.org/dc/terms/"/>
-    <ds:schemaRef ds:uri="http://schemas.microsoft.com/office/infopath/2007/PartnerControls"/>
-    <ds:schemaRef ds:uri="http://schemas.microsoft.com/office/2006/documentManagement/types"/>
-    <ds:schemaRef ds:uri="http://purl.org/dc/elements/1.1/"/>
-    <ds:schemaRef ds:uri="http://schemas.openxmlformats.org/package/2006/metadata/core-properties"/>
-    <ds:schemaRef ds:uri="71af3243-3dd4-4a8d-8c0d-dd76da1f02a5"/>
-    <ds:schemaRef ds:uri="http://purl.org/dc/dcmitype/"/>
-  </ds:schemaRefs>
-</ds:datastoreItem>
+<file path=customXml/item3.xml><?xml version="1.0" encoding="utf-8"?>
+<p:properties xmlns:p="http://schemas.microsoft.com/office/2006/metadata/properties" xmlns:xsi="http://www.w3.org/2001/XMLSchema-instance" xmlns:pc="http://schemas.microsoft.com/office/infopath/2007/PartnerControls">
+  <documentManagement>
+    <_ip_UnifiedCompliancePolicyUIAction xmlns="http://schemas.microsoft.com/sharepoint/v3" xsi:nil="true"/>
+    <Image xmlns="71af3243-3dd4-4a8d-8c0d-dd76da1f02a5">
+      <Url xsi:nil="true"/>
+      <Description xsi:nil="true"/>
+    </Image>
+    <Status xmlns="71af3243-3dd4-4a8d-8c0d-dd76da1f02a5">Not started</Status>
+    <Background xmlns="71af3243-3dd4-4a8d-8c0d-dd76da1f02a5">false</Background>
+    <_ip_UnifiedCompliancePolicyProperties xmlns="http://schemas.microsoft.com/sharepoint/v3" xsi:nil="true"/>
+    <ImageTagsTaxHTField xmlns="71af3243-3dd4-4a8d-8c0d-dd76da1f02a5">
+      <Terms xmlns="http://schemas.microsoft.com/office/infopath/2007/PartnerControls"/>
+    </ImageTagsTaxHTField>
+    <TaxCatchAll xmlns="230e9df3-be65-4c73-a93b-d1236ebd677e" xsi:nil="true"/>
+    <MediaServiceKeyPoints xmlns="71af3243-3dd4-4a8d-8c0d-dd76da1f02a5" xsi:nil="true"/>
+  </documentManagement>
+</p:properties>
 </file>
 
-<file path=customXml/itemProps2.xml><?xml version="1.0" encoding="utf-8"?>
+<file path=customXml/itemProps1.xml><?xml version="1.0" encoding="utf-8"?>
 <ds:datastoreItem xmlns:ds="http://schemas.openxmlformats.org/officeDocument/2006/customXml" ds:itemID="{78F2847D-96C7-4634-93AB-D232DDB6E5EB}">
   <ds:schemaRefs>
     <ds:schemaRef ds:uri="http://schemas.microsoft.com/sharepoint/v3/contenttype/forms"/>
@@ -24845,7 +24847,7 @@
 </ds:datastoreItem>
 </file>
 
-<file path=customXml/itemProps3.xml><?xml version="1.0" encoding="utf-8"?>
+<file path=customXml/itemProps2.xml><?xml version="1.0" encoding="utf-8"?>
 <ds:datastoreItem xmlns:ds="http://schemas.openxmlformats.org/officeDocument/2006/customXml" ds:itemID="{074F6EFD-5A76-4C77-A0A3-4BA9EAEE14E7}">
   <ds:schemaRefs>
     <ds:schemaRef ds:uri="http://schemas.microsoft.com/office/2006/metadata/contentType"/>
@@ -24866,6 +24868,25 @@
 </ds:datastoreItem>
 </file>
 
+<file path=customXml/itemProps3.xml><?xml version="1.0" encoding="utf-8"?>
+<ds:datastoreItem xmlns:ds="http://schemas.openxmlformats.org/officeDocument/2006/customXml" ds:itemID="{4D18307F-863E-465D-9426-B14DA0CBD25E}">
+  <ds:schemaRefs>
+    <ds:schemaRef ds:uri="http://schemas.microsoft.com/sharepoint/v3"/>
+    <ds:schemaRef ds:uri="16c05727-aa75-4e4a-9b5f-8a80a1165891"/>
+    <ds:schemaRef ds:uri="http://schemas.microsoft.com/office/2006/metadata/properties"/>
+    <ds:schemaRef ds:uri="http://www.w3.org/XML/1998/namespace"/>
+    <ds:schemaRef ds:uri="230e9df3-be65-4c73-a93b-d1236ebd677e"/>
+    <ds:schemaRef ds:uri="http://purl.org/dc/terms/"/>
+    <ds:schemaRef ds:uri="http://schemas.microsoft.com/office/infopath/2007/PartnerControls"/>
+    <ds:schemaRef ds:uri="http://schemas.microsoft.com/office/2006/documentManagement/types"/>
+    <ds:schemaRef ds:uri="http://purl.org/dc/elements/1.1/"/>
+    <ds:schemaRef ds:uri="http://schemas.openxmlformats.org/package/2006/metadata/core-properties"/>
+    <ds:schemaRef ds:uri="71af3243-3dd4-4a8d-8c0d-dd76da1f02a5"/>
+    <ds:schemaRef ds:uri="http://purl.org/dc/dcmitype/"/>
+  </ds:schemaRefs>
+</ds:datastoreItem>
+</file>
+
 <file path=docMetadata/LabelInfo.xml><?xml version="1.0" encoding="utf-8"?>
 <clbl:labelList xmlns:clbl="http://schemas.microsoft.com/office/2020/mipLabelMetadata"/>
 </file>
</xml_diff>